<commit_message>
feat: execute Roundveil Compact circuits in browser
</commit_message>
<xml_diff>
--- a/docs/Roundveil-Pitch.pptx
+++ b/docs/Roundveil-Pitch.pptx
@@ -2,17 +2,17 @@
 <file path=ppt/presentation.xml><?xml version="1.0" encoding="utf-8"?>
 <p:presentation xmlns:p="http://schemas.openxmlformats.org/presentationml/2006/main">
   <p:sldMasterIdLst>
-    <p:sldMasterId xmlns:r="http://schemas.openxmlformats.org/officeDocument/2006/relationships" id="2147483648" r:id="Rc60a78917f734d27"/>
+    <p:sldMasterId xmlns:r="http://schemas.openxmlformats.org/officeDocument/2006/relationships" id="2147483648" r:id="Rca8e0f00cc2540e6"/>
   </p:sldMasterIdLst>
   <p:notesMasterIdLst>
-    <p:notesMasterId xmlns:r="http://schemas.openxmlformats.org/officeDocument/2006/relationships" r:id="Rd0311479c3514e80"/>
+    <p:notesMasterId xmlns:r="http://schemas.openxmlformats.org/officeDocument/2006/relationships" r:id="Re9fa6797a36444ea"/>
   </p:notesMasterIdLst>
   <p:sldIdLst>
-    <p:sldId xmlns:r="http://schemas.openxmlformats.org/officeDocument/2006/relationships" id="256" r:id="R08349dedafbc4ac2"/>
-    <p:sldId xmlns:r="http://schemas.openxmlformats.org/officeDocument/2006/relationships" id="257" r:id="Rba60a6afb8a64d83"/>
-    <p:sldId xmlns:r="http://schemas.openxmlformats.org/officeDocument/2006/relationships" id="258" r:id="Re981cc9792aa435b"/>
-    <p:sldId xmlns:r="http://schemas.openxmlformats.org/officeDocument/2006/relationships" id="259" r:id="R2723f675f0704e2d"/>
-    <p:sldId xmlns:r="http://schemas.openxmlformats.org/officeDocument/2006/relationships" id="260" r:id="R9de3eefa342549b8"/>
+    <p:sldId xmlns:r="http://schemas.openxmlformats.org/officeDocument/2006/relationships" id="256" r:id="R018b1588c9b54b8d"/>
+    <p:sldId xmlns:r="http://schemas.openxmlformats.org/officeDocument/2006/relationships" id="257" r:id="R1d485f75e7474d0e"/>
+    <p:sldId xmlns:r="http://schemas.openxmlformats.org/officeDocument/2006/relationships" id="258" r:id="Rc0aa285de09e4d7d"/>
+    <p:sldId xmlns:r="http://schemas.openxmlformats.org/officeDocument/2006/relationships" id="259" r:id="Rd7677426d78b4069"/>
+    <p:sldId xmlns:r="http://schemas.openxmlformats.org/officeDocument/2006/relationships" id="260" r:id="R8663e916fe474c35"/>
   </p:sldIdLst>
   <p:sldSz cx="12192000" cy="6858000"/>
   <p:notesSz cx="6858000" cy="9144000"/>
@@ -773,7 +773,7 @@
           <p:cNvPr id="3" name="Title">
             <a:extLst xmlns:a="http://schemas.openxmlformats.org/drawingml/2006/main">
               <a:ext uri="{FF2B5EF4-FFF2-40B4-BE49-F238E27FC236}">
-                <a16:creationId xmlns:a16="http://schemas.microsoft.com/office/drawing/2014/main" id="{E10AD83A-2272-4E3E-B122-7808D37FFD0B}"/>
+                <a16:creationId xmlns:a16="http://schemas.microsoft.com/office/drawing/2014/main" id="{6FDD00A6-DCFA-48C6-9945-5E62D88176D5}"/>
               </a:ext>
             </a:extLst>
           </p:cNvPr>
@@ -1002,7 +1002,7 @@
           <p:cNvPr id="2" name="Subtitle">
             <a:extLst xmlns:a="http://schemas.openxmlformats.org/drawingml/2006/main">
               <a:ext uri="{FF2B5EF4-FFF2-40B4-BE49-F238E27FC236}">
-                <a16:creationId xmlns:a16="http://schemas.microsoft.com/office/drawing/2014/main" id="{62C5508F-6B76-42A4-B130-21E0807D27D0}"/>
+                <a16:creationId xmlns:a16="http://schemas.microsoft.com/office/drawing/2014/main" id="{394AA190-9327-419F-A07B-EA04D3FA5BC1}"/>
               </a:ext>
             </a:extLst>
           </p:cNvPr>
@@ -1248,7 +1248,7 @@
           <p:cNvPr id="2" name="Section title">
             <a:extLst xmlns:a="http://schemas.openxmlformats.org/drawingml/2006/main">
               <a:ext uri="{FF2B5EF4-FFF2-40B4-BE49-F238E27FC236}">
-                <a16:creationId xmlns:a16="http://schemas.microsoft.com/office/drawing/2014/main" id="{0A3F8B53-CE6F-495F-B0FA-D9527A9E4394}"/>
+                <a16:creationId xmlns:a16="http://schemas.microsoft.com/office/drawing/2014/main" id="{937943D3-FC3A-4281-A2F4-785E7685311F}"/>
               </a:ext>
             </a:extLst>
           </p:cNvPr>
@@ -1494,7 +1494,7 @@
           <p:cNvPr id="3" name="Title">
             <a:extLst xmlns:a="http://schemas.openxmlformats.org/drawingml/2006/main">
               <a:ext uri="{FF2B5EF4-FFF2-40B4-BE49-F238E27FC236}">
-                <a16:creationId xmlns:a16="http://schemas.microsoft.com/office/drawing/2014/main" id="{A6BA71E9-CA6C-477D-BA0B-A6A6925A4C11}"/>
+                <a16:creationId xmlns:a16="http://schemas.microsoft.com/office/drawing/2014/main" id="{9F0FEAC5-8781-47F7-833F-DA127DFC40C4}"/>
               </a:ext>
             </a:extLst>
           </p:cNvPr>
@@ -1723,7 +1723,7 @@
           <p:cNvPr id="2" name="Body">
             <a:extLst xmlns:a="http://schemas.openxmlformats.org/drawingml/2006/main">
               <a:ext uri="{FF2B5EF4-FFF2-40B4-BE49-F238E27FC236}">
-                <a16:creationId xmlns:a16="http://schemas.microsoft.com/office/drawing/2014/main" id="{41D52805-8B97-4C1D-A343-2ECF2A137AFD}"/>
+                <a16:creationId xmlns:a16="http://schemas.microsoft.com/office/drawing/2014/main" id="{C710DD90-275D-43CB-8252-4B4FD24E53E6}"/>
               </a:ext>
             </a:extLst>
           </p:cNvPr>
@@ -1969,7 +1969,7 @@
           <p:cNvPr id="4" name="Title">
             <a:extLst xmlns:a="http://schemas.openxmlformats.org/drawingml/2006/main">
               <a:ext uri="{FF2B5EF4-FFF2-40B4-BE49-F238E27FC236}">
-                <a16:creationId xmlns:a16="http://schemas.microsoft.com/office/drawing/2014/main" id="{49A2DCDD-56FC-428F-B164-9CD79A75BFBE}"/>
+                <a16:creationId xmlns:a16="http://schemas.microsoft.com/office/drawing/2014/main" id="{28166251-3A7A-4A46-AAF7-1B094CB24A2A}"/>
               </a:ext>
             </a:extLst>
           </p:cNvPr>
@@ -2198,7 +2198,7 @@
           <p:cNvPr id="2" name="Left column">
             <a:extLst xmlns:a="http://schemas.openxmlformats.org/drawingml/2006/main">
               <a:ext uri="{FF2B5EF4-FFF2-40B4-BE49-F238E27FC236}">
-                <a16:creationId xmlns:a16="http://schemas.microsoft.com/office/drawing/2014/main" id="{B4D27DEB-E2ED-4322-92E0-B2603226B4FD}"/>
+                <a16:creationId xmlns:a16="http://schemas.microsoft.com/office/drawing/2014/main" id="{20221641-A129-4CAB-9938-86F1B2F561B8}"/>
               </a:ext>
             </a:extLst>
           </p:cNvPr>
@@ -2427,7 +2427,7 @@
           <p:cNvPr id="3" name="Right column">
             <a:extLst xmlns:a="http://schemas.openxmlformats.org/drawingml/2006/main">
               <a:ext uri="{FF2B5EF4-FFF2-40B4-BE49-F238E27FC236}">
-                <a16:creationId xmlns:a16="http://schemas.microsoft.com/office/drawing/2014/main" id="{6F26672F-8430-4DCF-9DAA-F42A15D3366B}"/>
+                <a16:creationId xmlns:a16="http://schemas.microsoft.com/office/drawing/2014/main" id="{A92E11C0-6C20-4FCE-A4F1-9D117AC11124}"/>
               </a:ext>
             </a:extLst>
           </p:cNvPr>
@@ -2673,7 +2673,7 @@
           <p:cNvPr id="3" name="Title">
             <a:extLst xmlns:a="http://schemas.openxmlformats.org/drawingml/2006/main">
               <a:ext uri="{FF2B5EF4-FFF2-40B4-BE49-F238E27FC236}">
-                <a16:creationId xmlns:a16="http://schemas.microsoft.com/office/drawing/2014/main" id="{2D6AF1E3-C43A-4BDE-A8A3-77813D7F8586}"/>
+                <a16:creationId xmlns:a16="http://schemas.microsoft.com/office/drawing/2014/main" id="{C920FA1F-A718-4687-9030-77A0E45CD0DD}"/>
               </a:ext>
             </a:extLst>
           </p:cNvPr>
@@ -2902,7 +2902,7 @@
           <p:cNvPr id="2" name="Left column">
             <a:extLst xmlns:a="http://schemas.openxmlformats.org/drawingml/2006/main">
               <a:ext uri="{FF2B5EF4-FFF2-40B4-BE49-F238E27FC236}">
-                <a16:creationId xmlns:a16="http://schemas.microsoft.com/office/drawing/2014/main" id="{D5BD9EC6-3127-41C7-B100-ED9157869585}"/>
+                <a16:creationId xmlns:a16="http://schemas.microsoft.com/office/drawing/2014/main" id="{12B7C7D8-AEE8-41E4-A54A-D039F69D1D08}"/>
               </a:ext>
             </a:extLst>
           </p:cNvPr>
@@ -3169,12 +3169,12 @@
   </p:cSld>
   <p:clrMap bg1="lt1" tx1="dk1" bg2="lt2" tx2="dk2" accent1="accent1" accent2="accent2" accent3="accent3" accent4="accent4" accent5="accent5" accent6="accent6" hlink="hlink" folHlink="folHlink"/>
   <p:sldLayoutIdLst>
-    <p:sldLayoutId xmlns:r="http://schemas.openxmlformats.org/officeDocument/2006/relationships" id="2147483649" r:id="R5e486660edee4465"/>
-    <p:sldLayoutId xmlns:r="http://schemas.openxmlformats.org/officeDocument/2006/relationships" id="2147483650" r:id="Rab7eacadc5f64285"/>
-    <p:sldLayoutId xmlns:r="http://schemas.openxmlformats.org/officeDocument/2006/relationships" id="2147483651" r:id="R8185fdae3d0349ea"/>
-    <p:sldLayoutId xmlns:r="http://schemas.openxmlformats.org/officeDocument/2006/relationships" id="2147483652" r:id="Rb7792d19f086402e"/>
-    <p:sldLayoutId xmlns:r="http://schemas.openxmlformats.org/officeDocument/2006/relationships" id="2147483653" r:id="R697e78305e78470f"/>
-    <p:sldLayoutId xmlns:r="http://schemas.openxmlformats.org/officeDocument/2006/relationships" id="2147483654" r:id="R586c59e3e6e944ec"/>
+    <p:sldLayoutId xmlns:r="http://schemas.openxmlformats.org/officeDocument/2006/relationships" id="2147483649" r:id="Rafacfd1ec2084a20"/>
+    <p:sldLayoutId xmlns:r="http://schemas.openxmlformats.org/officeDocument/2006/relationships" id="2147483650" r:id="R4ffdb145a5dd4f33"/>
+    <p:sldLayoutId xmlns:r="http://schemas.openxmlformats.org/officeDocument/2006/relationships" id="2147483651" r:id="Rd513955032174c75"/>
+    <p:sldLayoutId xmlns:r="http://schemas.openxmlformats.org/officeDocument/2006/relationships" id="2147483652" r:id="R745660e5b8b84d6d"/>
+    <p:sldLayoutId xmlns:r="http://schemas.openxmlformats.org/officeDocument/2006/relationships" id="2147483653" r:id="R279424bbac784fbb"/>
+    <p:sldLayoutId xmlns:r="http://schemas.openxmlformats.org/officeDocument/2006/relationships" id="2147483654" r:id="Rd01d6b98c15c448d"/>
   </p:sldLayoutIdLst>
   <p:txStyles>
     <p:titleStyle>
@@ -3725,7 +3725,7 @@
           <p:cNvPr id="9" name="cover-accent">
             <a:extLst xmlns:a="http://schemas.openxmlformats.org/drawingml/2006/main">
               <a:ext uri="{FF2B5EF4-FFF2-40B4-BE49-F238E27FC236}">
-                <a16:creationId xmlns:a16="http://schemas.microsoft.com/office/drawing/2014/main" id="{4DAE51E4-3486-4B8D-AA61-4F424896D138}"/>
+                <a16:creationId xmlns:a16="http://schemas.microsoft.com/office/drawing/2014/main" id="{041ABA96-C92C-4BAC-9981-F70F09CCED9C}"/>
               </a:ext>
             </a:extLst>
           </p:cNvPr>
@@ -3756,7 +3756,7 @@
           <p:cNvPr id="2" name="cover-brand">
             <a:extLst xmlns:a="http://schemas.openxmlformats.org/drawingml/2006/main">
               <a:ext uri="{FF2B5EF4-FFF2-40B4-BE49-F238E27FC236}">
-                <a16:creationId xmlns:a16="http://schemas.microsoft.com/office/drawing/2014/main" id="{753DA9D1-66D3-418A-B879-C75F81D7DA6F}"/>
+                <a16:creationId xmlns:a16="http://schemas.microsoft.com/office/drawing/2014/main" id="{5107124C-79F8-41DF-B8B8-3FBB5592DD3D}"/>
               </a:ext>
             </a:extLst>
           </p:cNvPr>
@@ -3913,7 +3913,7 @@
           <p:cNvPr id="3" name="cover-description">
             <a:extLst xmlns:a="http://schemas.openxmlformats.org/drawingml/2006/main">
               <a:ext uri="{FF2B5EF4-FFF2-40B4-BE49-F238E27FC236}">
-                <a16:creationId xmlns:a16="http://schemas.microsoft.com/office/drawing/2014/main" id="{DE2CCEEF-525D-4A75-93A6-C36B1236BBD5}"/>
+                <a16:creationId xmlns:a16="http://schemas.microsoft.com/office/drawing/2014/main" id="{8514601A-1486-4C33-BB46-23DC5B01CBCF}"/>
               </a:ext>
             </a:extLst>
           </p:cNvPr>
@@ -4093,7 +4093,7 @@
           <p:cNvPr id="4" name="cover-support">
             <a:extLst xmlns:a="http://schemas.openxmlformats.org/drawingml/2006/main">
               <a:ext uri="{FF2B5EF4-FFF2-40B4-BE49-F238E27FC236}">
-                <a16:creationId xmlns:a16="http://schemas.microsoft.com/office/drawing/2014/main" id="{E9C2F9D3-EBA4-4060-BAEE-6918CD021214}"/>
+                <a16:creationId xmlns:a16="http://schemas.microsoft.com/office/drawing/2014/main" id="{ECE7EC14-F9BB-4536-A539-51B4C784C372}"/>
               </a:ext>
             </a:extLst>
           </p:cNvPr>
@@ -4250,7 +4250,7 @@
           <p:cNvPr id="5" name="cover-rule">
             <a:extLst xmlns:a="http://schemas.openxmlformats.org/drawingml/2006/main">
               <a:ext uri="{FF2B5EF4-FFF2-40B4-BE49-F238E27FC236}">
-                <a16:creationId xmlns:a16="http://schemas.microsoft.com/office/drawing/2014/main" id="{C0D4056F-5D0A-4254-A745-C98D7CF34F26}"/>
+                <a16:creationId xmlns:a16="http://schemas.microsoft.com/office/drawing/2014/main" id="{190E1FA4-505F-44C0-A14F-8A5597590F16}"/>
               </a:ext>
             </a:extLst>
           </p:cNvPr>
@@ -4281,7 +4281,7 @@
           <p:cNvPr id="6" name="cover-wave">
             <a:extLst xmlns:a="http://schemas.openxmlformats.org/drawingml/2006/main">
               <a:ext uri="{FF2B5EF4-FFF2-40B4-BE49-F238E27FC236}">
-                <a16:creationId xmlns:a16="http://schemas.microsoft.com/office/drawing/2014/main" id="{686D9FC7-FAB2-474D-BDF9-CBCB245560DF}"/>
+                <a16:creationId xmlns:a16="http://schemas.microsoft.com/office/drawing/2014/main" id="{8C002940-2E18-4987-AB01-A08C444215D2}"/>
               </a:ext>
             </a:extLst>
           </p:cNvPr>
@@ -4438,7 +4438,7 @@
           <p:cNvPr id="7" name="cover-status">
             <a:extLst xmlns:a="http://schemas.openxmlformats.org/drawingml/2006/main">
               <a:ext uri="{FF2B5EF4-FFF2-40B4-BE49-F238E27FC236}">
-                <a16:creationId xmlns:a16="http://schemas.microsoft.com/office/drawing/2014/main" id="{7DF22C22-ED95-422D-A502-66178A8E3522}"/>
+                <a16:creationId xmlns:a16="http://schemas.microsoft.com/office/drawing/2014/main" id="{9A1372FA-FA19-4D17-AE4C-54838AD1E3BB}"/>
               </a:ext>
             </a:extLst>
           </p:cNvPr>
@@ -4595,7 +4595,7 @@
           <p:cNvPr id="8" name="cover-cycle">
             <a:extLst xmlns:a="http://schemas.openxmlformats.org/drawingml/2006/main">
               <a:ext uri="{FF2B5EF4-FFF2-40B4-BE49-F238E27FC236}">
-                <a16:creationId xmlns:a16="http://schemas.microsoft.com/office/drawing/2014/main" id="{701030B9-870A-4100-B599-667740C4670B}"/>
+                <a16:creationId xmlns:a16="http://schemas.microsoft.com/office/drawing/2014/main" id="{405AD264-BD53-4549-A1FA-63F92B006F3A}"/>
               </a:ext>
             </a:extLst>
           </p:cNvPr>
@@ -4750,7 +4750,7 @@
     </p:spTree>
     <p:extLst>
       <p:ext uri="{BB962C8B-B14F-4D97-AF65-F5344CB8AC3E}">
-        <p14:creationId xmlns:p14="http://schemas.microsoft.com/office/powerpoint/2010/main" val="1271711517"/>
+        <p14:creationId xmlns:p14="http://schemas.microsoft.com/office/powerpoint/2010/main" val="556308482"/>
       </p:ext>
     </p:extLst>
   </p:cSld>
@@ -4781,7 +4781,7 @@
           <p:cNvPr id="11" name="s2-kicker">
             <a:extLst xmlns:a="http://schemas.openxmlformats.org/drawingml/2006/main">
               <a:ext uri="{FF2B5EF4-FFF2-40B4-BE49-F238E27FC236}">
-                <a16:creationId xmlns:a16="http://schemas.microsoft.com/office/drawing/2014/main" id="{C613F8E9-18A9-48D4-A22B-4327E0214C07}"/>
+                <a16:creationId xmlns:a16="http://schemas.microsoft.com/office/drawing/2014/main" id="{494F916E-08CD-4ACA-A728-27CD5D3FF703}"/>
               </a:ext>
             </a:extLst>
           </p:cNvPr>
@@ -4938,7 +4938,7 @@
           <p:cNvPr id="2" name="s2-title">
             <a:extLst xmlns:a="http://schemas.openxmlformats.org/drawingml/2006/main">
               <a:ext uri="{FF2B5EF4-FFF2-40B4-BE49-F238E27FC236}">
-                <a16:creationId xmlns:a16="http://schemas.microsoft.com/office/drawing/2014/main" id="{6065E225-AE21-4818-89D4-B3373E3D8A6B}"/>
+                <a16:creationId xmlns:a16="http://schemas.microsoft.com/office/drawing/2014/main" id="{46741CDC-8185-4C23-B32A-3E0AE121C2FE}"/>
               </a:ext>
             </a:extLst>
           </p:cNvPr>
@@ -5095,7 +5095,7 @@
           <p:cNvPr id="3" name="s2-left-label">
             <a:extLst xmlns:a="http://schemas.openxmlformats.org/drawingml/2006/main">
               <a:ext uri="{FF2B5EF4-FFF2-40B4-BE49-F238E27FC236}">
-                <a16:creationId xmlns:a16="http://schemas.microsoft.com/office/drawing/2014/main" id="{7BA557F6-B2E9-4D83-A692-8E0C1FA638F9}"/>
+                <a16:creationId xmlns:a16="http://schemas.microsoft.com/office/drawing/2014/main" id="{2853AB31-B239-4ECC-870D-8BBD6A40BF9F}"/>
               </a:ext>
             </a:extLst>
           </p:cNvPr>
@@ -5252,7 +5252,7 @@
           <p:cNvPr id="4" name="s2-left-body">
             <a:extLst xmlns:a="http://schemas.openxmlformats.org/drawingml/2006/main">
               <a:ext uri="{FF2B5EF4-FFF2-40B4-BE49-F238E27FC236}">
-                <a16:creationId xmlns:a16="http://schemas.microsoft.com/office/drawing/2014/main" id="{1460AC0D-DB3F-4543-AA45-4D05792CA7DD}"/>
+                <a16:creationId xmlns:a16="http://schemas.microsoft.com/office/drawing/2014/main" id="{D96F2AE6-DF9E-4B4E-9111-D799375985D2}"/>
               </a:ext>
             </a:extLst>
           </p:cNvPr>
@@ -5432,7 +5432,7 @@
           <p:cNvPr id="5" name="s2-left-foot">
             <a:extLst xmlns:a="http://schemas.openxmlformats.org/drawingml/2006/main">
               <a:ext uri="{FF2B5EF4-FFF2-40B4-BE49-F238E27FC236}">
-                <a16:creationId xmlns:a16="http://schemas.microsoft.com/office/drawing/2014/main" id="{99F3ED26-21A5-4261-B7EB-71C3E3C1EB5E}"/>
+                <a16:creationId xmlns:a16="http://schemas.microsoft.com/office/drawing/2014/main" id="{1FA78FE8-607C-4676-B411-440F3DED7DE2}"/>
               </a:ext>
             </a:extLst>
           </p:cNvPr>
@@ -5589,7 +5589,7 @@
           <p:cNvPr id="6" name="s2-divider">
             <a:extLst xmlns:a="http://schemas.openxmlformats.org/drawingml/2006/main">
               <a:ext uri="{FF2B5EF4-FFF2-40B4-BE49-F238E27FC236}">
-                <a16:creationId xmlns:a16="http://schemas.microsoft.com/office/drawing/2014/main" id="{79D50413-F95C-47B1-9ABA-361977E3A9F3}"/>
+                <a16:creationId xmlns:a16="http://schemas.microsoft.com/office/drawing/2014/main" id="{E9B5D7C4-C6D3-43DD-B770-F9C23D819947}"/>
               </a:ext>
             </a:extLst>
           </p:cNvPr>
@@ -5620,7 +5620,7 @@
           <p:cNvPr id="7" name="s2-right-label">
             <a:extLst xmlns:a="http://schemas.openxmlformats.org/drawingml/2006/main">
               <a:ext uri="{FF2B5EF4-FFF2-40B4-BE49-F238E27FC236}">
-                <a16:creationId xmlns:a16="http://schemas.microsoft.com/office/drawing/2014/main" id="{FB08AE72-29DE-4E95-BDCA-E439A30DF82B}"/>
+                <a16:creationId xmlns:a16="http://schemas.microsoft.com/office/drawing/2014/main" id="{5F1E09C4-DE3A-4000-AAF5-501A3FDE1BAA}"/>
               </a:ext>
             </a:extLst>
           </p:cNvPr>
@@ -5777,7 +5777,7 @@
           <p:cNvPr id="8" name="s2-right-body">
             <a:extLst xmlns:a="http://schemas.openxmlformats.org/drawingml/2006/main">
               <a:ext uri="{FF2B5EF4-FFF2-40B4-BE49-F238E27FC236}">
-                <a16:creationId xmlns:a16="http://schemas.microsoft.com/office/drawing/2014/main" id="{FF82DFC4-BA19-4243-AF57-015683BA231A}"/>
+                <a16:creationId xmlns:a16="http://schemas.microsoft.com/office/drawing/2014/main" id="{BC8AAA04-0FC3-4A53-AF93-A6BC7CD6E826}"/>
               </a:ext>
             </a:extLst>
           </p:cNvPr>
@@ -5980,7 +5980,7 @@
           <p:cNvPr id="9" name="s2-right-foot">
             <a:extLst xmlns:a="http://schemas.openxmlformats.org/drawingml/2006/main">
               <a:ext uri="{FF2B5EF4-FFF2-40B4-BE49-F238E27FC236}">
-                <a16:creationId xmlns:a16="http://schemas.microsoft.com/office/drawing/2014/main" id="{128B61EE-5D80-4510-BA5B-FEBAAAC368D2}"/>
+                <a16:creationId xmlns:a16="http://schemas.microsoft.com/office/drawing/2014/main" id="{FFD5AE3C-16C2-4A1A-8787-C10A47D0967C}"/>
               </a:ext>
             </a:extLst>
           </p:cNvPr>
@@ -6137,7 +6137,7 @@
           <p:cNvPr id="10" name="s2-footer">
             <a:extLst xmlns:a="http://schemas.openxmlformats.org/drawingml/2006/main">
               <a:ext uri="{FF2B5EF4-FFF2-40B4-BE49-F238E27FC236}">
-                <a16:creationId xmlns:a16="http://schemas.microsoft.com/office/drawing/2014/main" id="{FC34B576-BCBC-490A-8ABC-8C4137F39E81}"/>
+                <a16:creationId xmlns:a16="http://schemas.microsoft.com/office/drawing/2014/main" id="{726FB94D-6DAC-4C2F-91A3-CED155417A08}"/>
               </a:ext>
             </a:extLst>
           </p:cNvPr>
@@ -6292,7 +6292,7 @@
     </p:spTree>
     <p:extLst>
       <p:ext uri="{BB962C8B-B14F-4D97-AF65-F5344CB8AC3E}">
-        <p14:creationId xmlns:p14="http://schemas.microsoft.com/office/powerpoint/2010/main" val="1027201892"/>
+        <p14:creationId xmlns:p14="http://schemas.microsoft.com/office/powerpoint/2010/main" val="463406952"/>
       </p:ext>
     </p:extLst>
   </p:cSld>
@@ -6323,7 +6323,7 @@
           <p:cNvPr id="18" name="s3-kicker">
             <a:extLst xmlns:a="http://schemas.openxmlformats.org/drawingml/2006/main">
               <a:ext uri="{FF2B5EF4-FFF2-40B4-BE49-F238E27FC236}">
-                <a16:creationId xmlns:a16="http://schemas.microsoft.com/office/drawing/2014/main" id="{A2521AF6-A9AF-4A9A-9F2B-59AE03EB76B7}"/>
+                <a16:creationId xmlns:a16="http://schemas.microsoft.com/office/drawing/2014/main" id="{D62625B4-2268-4F64-97CB-648532652EAA}"/>
               </a:ext>
             </a:extLst>
           </p:cNvPr>
@@ -6480,7 +6480,7 @@
           <p:cNvPr id="2" name="s3-title">
             <a:extLst xmlns:a="http://schemas.openxmlformats.org/drawingml/2006/main">
               <a:ext uri="{FF2B5EF4-FFF2-40B4-BE49-F238E27FC236}">
-                <a16:creationId xmlns:a16="http://schemas.microsoft.com/office/drawing/2014/main" id="{F94CED5C-F9B9-4FE1-B925-5345547EAD39}"/>
+                <a16:creationId xmlns:a16="http://schemas.microsoft.com/office/drawing/2014/main" id="{7837DB6C-C1E6-44A7-8F58-7490BFAC04C7}"/>
               </a:ext>
             </a:extLst>
           </p:cNvPr>
@@ -6637,7 +6637,7 @@
           <p:cNvPr id="3" name="s3-number-0">
             <a:extLst xmlns:a="http://schemas.openxmlformats.org/drawingml/2006/main">
               <a:ext uri="{FF2B5EF4-FFF2-40B4-BE49-F238E27FC236}">
-                <a16:creationId xmlns:a16="http://schemas.microsoft.com/office/drawing/2014/main" id="{F0A39F37-798F-47F4-AC80-B08CB317696D}"/>
+                <a16:creationId xmlns:a16="http://schemas.microsoft.com/office/drawing/2014/main" id="{B6DC5CBC-CF05-4FB1-8AAF-0FC04B42DA08}"/>
               </a:ext>
             </a:extLst>
           </p:cNvPr>
@@ -6794,7 +6794,7 @@
           <p:cNvPr id="4" name="s3-step-rule-0">
             <a:extLst xmlns:a="http://schemas.openxmlformats.org/drawingml/2006/main">
               <a:ext uri="{FF2B5EF4-FFF2-40B4-BE49-F238E27FC236}">
-                <a16:creationId xmlns:a16="http://schemas.microsoft.com/office/drawing/2014/main" id="{C1031568-8D0E-44B8-853C-B4C6E930F4FC}"/>
+                <a16:creationId xmlns:a16="http://schemas.microsoft.com/office/drawing/2014/main" id="{66A6EF05-EA98-43EF-AD71-48B5703D6C94}"/>
               </a:ext>
             </a:extLst>
           </p:cNvPr>
@@ -6825,7 +6825,7 @@
           <p:cNvPr id="5" name="s3-step-title-0">
             <a:extLst xmlns:a="http://schemas.openxmlformats.org/drawingml/2006/main">
               <a:ext uri="{FF2B5EF4-FFF2-40B4-BE49-F238E27FC236}">
-                <a16:creationId xmlns:a16="http://schemas.microsoft.com/office/drawing/2014/main" id="{19792EDF-69D8-4383-9DC8-0A98BFBE8FE8}"/>
+                <a16:creationId xmlns:a16="http://schemas.microsoft.com/office/drawing/2014/main" id="{C80C9CA3-2287-43D7-BEFB-53C64438474E}"/>
               </a:ext>
             </a:extLst>
           </p:cNvPr>
@@ -6982,7 +6982,7 @@
           <p:cNvPr id="6" name="s3-step-body-0">
             <a:extLst xmlns:a="http://schemas.openxmlformats.org/drawingml/2006/main">
               <a:ext uri="{FF2B5EF4-FFF2-40B4-BE49-F238E27FC236}">
-                <a16:creationId xmlns:a16="http://schemas.microsoft.com/office/drawing/2014/main" id="{868292BC-0F50-4877-B894-67E6A671648E}"/>
+                <a16:creationId xmlns:a16="http://schemas.microsoft.com/office/drawing/2014/main" id="{4AC13EF3-4412-43D2-BDA6-3179443D7D93}"/>
               </a:ext>
             </a:extLst>
           </p:cNvPr>
@@ -7139,7 +7139,7 @@
           <p:cNvPr id="7" name="s3-number-1">
             <a:extLst xmlns:a="http://schemas.openxmlformats.org/drawingml/2006/main">
               <a:ext uri="{FF2B5EF4-FFF2-40B4-BE49-F238E27FC236}">
-                <a16:creationId xmlns:a16="http://schemas.microsoft.com/office/drawing/2014/main" id="{31B090F5-5CE2-4C52-8092-7EDBF6EE37A0}"/>
+                <a16:creationId xmlns:a16="http://schemas.microsoft.com/office/drawing/2014/main" id="{AEC20EC5-5840-45F2-9DE6-15E68AB46691}"/>
               </a:ext>
             </a:extLst>
           </p:cNvPr>
@@ -7296,7 +7296,7 @@
           <p:cNvPr id="8" name="s3-step-rule-1">
             <a:extLst xmlns:a="http://schemas.openxmlformats.org/drawingml/2006/main">
               <a:ext uri="{FF2B5EF4-FFF2-40B4-BE49-F238E27FC236}">
-                <a16:creationId xmlns:a16="http://schemas.microsoft.com/office/drawing/2014/main" id="{C128AA5B-3AF0-4AA8-86E3-B2F50825DCC9}"/>
+                <a16:creationId xmlns:a16="http://schemas.microsoft.com/office/drawing/2014/main" id="{E8D1C736-BD1D-44CE-B629-779393560D1A}"/>
               </a:ext>
             </a:extLst>
           </p:cNvPr>
@@ -7327,7 +7327,7 @@
           <p:cNvPr id="9" name="s3-step-title-1">
             <a:extLst xmlns:a="http://schemas.openxmlformats.org/drawingml/2006/main">
               <a:ext uri="{FF2B5EF4-FFF2-40B4-BE49-F238E27FC236}">
-                <a16:creationId xmlns:a16="http://schemas.microsoft.com/office/drawing/2014/main" id="{B037B69E-CFFF-4DF3-87C9-37FA6127C419}"/>
+                <a16:creationId xmlns:a16="http://schemas.microsoft.com/office/drawing/2014/main" id="{677C54FC-778B-4AAB-98B0-670C08A4EF12}"/>
               </a:ext>
             </a:extLst>
           </p:cNvPr>
@@ -7484,7 +7484,7 @@
           <p:cNvPr id="10" name="s3-step-body-1">
             <a:extLst xmlns:a="http://schemas.openxmlformats.org/drawingml/2006/main">
               <a:ext uri="{FF2B5EF4-FFF2-40B4-BE49-F238E27FC236}">
-                <a16:creationId xmlns:a16="http://schemas.microsoft.com/office/drawing/2014/main" id="{E86F7592-C11E-47AF-A5FD-7F9207F14D98}"/>
+                <a16:creationId xmlns:a16="http://schemas.microsoft.com/office/drawing/2014/main" id="{EB6EC20D-A061-4027-A7B9-3E520A104A6D}"/>
               </a:ext>
             </a:extLst>
           </p:cNvPr>
@@ -7641,7 +7641,7 @@
           <p:cNvPr id="11" name="s3-number-2">
             <a:extLst xmlns:a="http://schemas.openxmlformats.org/drawingml/2006/main">
               <a:ext uri="{FF2B5EF4-FFF2-40B4-BE49-F238E27FC236}">
-                <a16:creationId xmlns:a16="http://schemas.microsoft.com/office/drawing/2014/main" id="{3711CC81-269C-45FF-8533-D33D367CB468}"/>
+                <a16:creationId xmlns:a16="http://schemas.microsoft.com/office/drawing/2014/main" id="{00904873-3FC2-4899-B627-33D0DFD705D6}"/>
               </a:ext>
             </a:extLst>
           </p:cNvPr>
@@ -7798,7 +7798,7 @@
           <p:cNvPr id="12" name="s3-step-rule-2">
             <a:extLst xmlns:a="http://schemas.openxmlformats.org/drawingml/2006/main">
               <a:ext uri="{FF2B5EF4-FFF2-40B4-BE49-F238E27FC236}">
-                <a16:creationId xmlns:a16="http://schemas.microsoft.com/office/drawing/2014/main" id="{AD2730C0-8EB1-4DF1-8C22-EA629321BD89}"/>
+                <a16:creationId xmlns:a16="http://schemas.microsoft.com/office/drawing/2014/main" id="{CAC2A2B0-0E5D-4FFA-8E40-F31D8A388772}"/>
               </a:ext>
             </a:extLst>
           </p:cNvPr>
@@ -7829,7 +7829,7 @@
           <p:cNvPr id="13" name="s3-step-title-2">
             <a:extLst xmlns:a="http://schemas.openxmlformats.org/drawingml/2006/main">
               <a:ext uri="{FF2B5EF4-FFF2-40B4-BE49-F238E27FC236}">
-                <a16:creationId xmlns:a16="http://schemas.microsoft.com/office/drawing/2014/main" id="{3F716DA1-4E3B-4182-AD36-386874BCDEEA}"/>
+                <a16:creationId xmlns:a16="http://schemas.microsoft.com/office/drawing/2014/main" id="{AB73FEC9-A3BB-4E98-A348-A8D06561DB7C}"/>
               </a:ext>
             </a:extLst>
           </p:cNvPr>
@@ -7986,7 +7986,7 @@
           <p:cNvPr id="14" name="s3-step-body-2">
             <a:extLst xmlns:a="http://schemas.openxmlformats.org/drawingml/2006/main">
               <a:ext uri="{FF2B5EF4-FFF2-40B4-BE49-F238E27FC236}">
-                <a16:creationId xmlns:a16="http://schemas.microsoft.com/office/drawing/2014/main" id="{D139F429-99B5-4E94-A8F3-59D3901CCF2E}"/>
+                <a16:creationId xmlns:a16="http://schemas.microsoft.com/office/drawing/2014/main" id="{493D608F-FDF8-4DB0-83A0-EDF9CCB057AE}"/>
               </a:ext>
             </a:extLst>
           </p:cNvPr>
@@ -8143,7 +8143,7 @@
           <p:cNvPr id="15" name="s3-status-strip">
             <a:extLst xmlns:a="http://schemas.openxmlformats.org/drawingml/2006/main">
               <a:ext uri="{FF2B5EF4-FFF2-40B4-BE49-F238E27FC236}">
-                <a16:creationId xmlns:a16="http://schemas.microsoft.com/office/drawing/2014/main" id="{FBACFD83-AA22-432D-9F1D-ED4937982329}"/>
+                <a16:creationId xmlns:a16="http://schemas.microsoft.com/office/drawing/2014/main" id="{FAED643F-74E0-49C7-99E9-42F98A9BB0DD}"/>
               </a:ext>
             </a:extLst>
           </p:cNvPr>
@@ -8174,7 +8174,7 @@
           <p:cNvPr id="16" name="s3-status">
             <a:extLst xmlns:a="http://schemas.openxmlformats.org/drawingml/2006/main">
               <a:ext uri="{FF2B5EF4-FFF2-40B4-BE49-F238E27FC236}">
-                <a16:creationId xmlns:a16="http://schemas.microsoft.com/office/drawing/2014/main" id="{52E65E19-9034-48B8-9B50-7057DF421982}"/>
+                <a16:creationId xmlns:a16="http://schemas.microsoft.com/office/drawing/2014/main" id="{16C98455-49DB-435F-B0D0-987774382986}"/>
               </a:ext>
             </a:extLst>
           </p:cNvPr>
@@ -8321,7 +8321,7 @@
                 <a:ea typeface="Arial"/>
                 <a:cs typeface="Arial"/>
               </a:rPr>
-              <a:t>NOW  ·  Local eligibility preview</a:t>
+              <a:t>NOW  ·  Compiled circuits in browser</a:t>
             </a:r>
           </a:p>
         </p:txBody>
@@ -8331,7 +8331,7 @@
           <p:cNvPr id="17" name="s3-next">
             <a:extLst xmlns:a="http://schemas.openxmlformats.org/drawingml/2006/main">
               <a:ext uri="{FF2B5EF4-FFF2-40B4-BE49-F238E27FC236}">
-                <a16:creationId xmlns:a16="http://schemas.microsoft.com/office/drawing/2014/main" id="{F5E84321-5A2C-4496-876E-410D0F57FC23}"/>
+                <a16:creationId xmlns:a16="http://schemas.microsoft.com/office/drawing/2014/main" id="{1403DFA9-4944-4870-AE74-DFA7A47607CD}"/>
               </a:ext>
             </a:extLst>
           </p:cNvPr>
@@ -8486,7 +8486,7 @@
     </p:spTree>
     <p:extLst>
       <p:ext uri="{BB962C8B-B14F-4D97-AF65-F5344CB8AC3E}">
-        <p14:creationId xmlns:p14="http://schemas.microsoft.com/office/powerpoint/2010/main" val="1496685150"/>
+        <p14:creationId xmlns:p14="http://schemas.microsoft.com/office/powerpoint/2010/main" val="137910373"/>
       </p:ext>
     </p:extLst>
   </p:cSld>
@@ -8517,7 +8517,7 @@
           <p:cNvPr id="24" name="s4-kicker">
             <a:extLst xmlns:a="http://schemas.openxmlformats.org/drawingml/2006/main">
               <a:ext uri="{FF2B5EF4-FFF2-40B4-BE49-F238E27FC236}">
-                <a16:creationId xmlns:a16="http://schemas.microsoft.com/office/drawing/2014/main" id="{F7FB5D5C-43D0-47B7-8E7B-B749A75CA7B0}"/>
+                <a16:creationId xmlns:a16="http://schemas.microsoft.com/office/drawing/2014/main" id="{673A648D-AF01-461D-96BE-6B20486CFFCF}"/>
               </a:ext>
             </a:extLst>
           </p:cNvPr>
@@ -8674,7 +8674,7 @@
           <p:cNvPr id="2" name="s4-title">
             <a:extLst xmlns:a="http://schemas.openxmlformats.org/drawingml/2006/main">
               <a:ext uri="{FF2B5EF4-FFF2-40B4-BE49-F238E27FC236}">
-                <a16:creationId xmlns:a16="http://schemas.microsoft.com/office/drawing/2014/main" id="{D8DA7D73-B76A-47EC-B993-38A8EA2BA19A}"/>
+                <a16:creationId xmlns:a16="http://schemas.microsoft.com/office/drawing/2014/main" id="{17412846-70CA-4F2F-9EDA-92A09A322AFB}"/>
               </a:ext>
             </a:extLst>
           </p:cNvPr>
@@ -8831,7 +8831,7 @@
           <p:cNvPr id="3" name="s4-private-head">
             <a:extLst xmlns:a="http://schemas.openxmlformats.org/drawingml/2006/main">
               <a:ext uri="{FF2B5EF4-FFF2-40B4-BE49-F238E27FC236}">
-                <a16:creationId xmlns:a16="http://schemas.microsoft.com/office/drawing/2014/main" id="{5EC4C745-7F95-44C5-808A-E8E48C77A1B0}"/>
+                <a16:creationId xmlns:a16="http://schemas.microsoft.com/office/drawing/2014/main" id="{8B54AF21-D882-4BD9-B076-C44AC8B054AE}"/>
               </a:ext>
             </a:extLst>
           </p:cNvPr>
@@ -8988,7 +8988,7 @@
           <p:cNvPr id="4" name="s4-public-head">
             <a:extLst xmlns:a="http://schemas.openxmlformats.org/drawingml/2006/main">
               <a:ext uri="{FF2B5EF4-FFF2-40B4-BE49-F238E27FC236}">
-                <a16:creationId xmlns:a16="http://schemas.microsoft.com/office/drawing/2014/main" id="{A4901A60-7890-49FD-9DF6-B6624560336F}"/>
+                <a16:creationId xmlns:a16="http://schemas.microsoft.com/office/drawing/2014/main" id="{57B95E42-5F84-41E1-8BAD-DD1ED1846AA7}"/>
               </a:ext>
             </a:extLst>
           </p:cNvPr>
@@ -9145,7 +9145,7 @@
           <p:cNvPr id="5" name="s4-private-head-rule">
             <a:extLst xmlns:a="http://schemas.openxmlformats.org/drawingml/2006/main">
               <a:ext uri="{FF2B5EF4-FFF2-40B4-BE49-F238E27FC236}">
-                <a16:creationId xmlns:a16="http://schemas.microsoft.com/office/drawing/2014/main" id="{61A53FFC-A7C1-4978-B969-BA72C1EBC670}"/>
+                <a16:creationId xmlns:a16="http://schemas.microsoft.com/office/drawing/2014/main" id="{4BD907E8-5472-4417-B5BC-0E0194D67AA8}"/>
               </a:ext>
             </a:extLst>
           </p:cNvPr>
@@ -9176,7 +9176,7 @@
           <p:cNvPr id="6" name="s4-public-head-rule">
             <a:extLst xmlns:a="http://schemas.openxmlformats.org/drawingml/2006/main">
               <a:ext uri="{FF2B5EF4-FFF2-40B4-BE49-F238E27FC236}">
-                <a16:creationId xmlns:a16="http://schemas.microsoft.com/office/drawing/2014/main" id="{6549C8E3-C975-4F2D-B673-0D35B62606E8}"/>
+                <a16:creationId xmlns:a16="http://schemas.microsoft.com/office/drawing/2014/main" id="{7D60128D-03CE-4FCE-A527-506443245815}"/>
               </a:ext>
             </a:extLst>
           </p:cNvPr>
@@ -9207,7 +9207,7 @@
           <p:cNvPr id="7" name="s4-left-0">
             <a:extLst xmlns:a="http://schemas.openxmlformats.org/drawingml/2006/main">
               <a:ext uri="{FF2B5EF4-FFF2-40B4-BE49-F238E27FC236}">
-                <a16:creationId xmlns:a16="http://schemas.microsoft.com/office/drawing/2014/main" id="{C2D793AA-6740-443C-817B-9623EBA3A55C}"/>
+                <a16:creationId xmlns:a16="http://schemas.microsoft.com/office/drawing/2014/main" id="{D2A8795D-1EA3-43C3-A351-801E0A00CBB0}"/>
               </a:ext>
             </a:extLst>
           </p:cNvPr>
@@ -9364,7 +9364,7 @@
           <p:cNvPr id="8" name="s4-right-0">
             <a:extLst xmlns:a="http://schemas.openxmlformats.org/drawingml/2006/main">
               <a:ext uri="{FF2B5EF4-FFF2-40B4-BE49-F238E27FC236}">
-                <a16:creationId xmlns:a16="http://schemas.microsoft.com/office/drawing/2014/main" id="{E90FC017-E42B-4F11-B303-5DFC768B47B7}"/>
+                <a16:creationId xmlns:a16="http://schemas.microsoft.com/office/drawing/2014/main" id="{D9E43EA3-73CB-426D-898E-D00B2120F553}"/>
               </a:ext>
             </a:extLst>
           </p:cNvPr>
@@ -9521,7 +9521,7 @@
           <p:cNvPr id="9" name="s4-left-rule-0">
             <a:extLst xmlns:a="http://schemas.openxmlformats.org/drawingml/2006/main">
               <a:ext uri="{FF2B5EF4-FFF2-40B4-BE49-F238E27FC236}">
-                <a16:creationId xmlns:a16="http://schemas.microsoft.com/office/drawing/2014/main" id="{AF935DE7-4449-4E57-8EAE-F430B7A043CA}"/>
+                <a16:creationId xmlns:a16="http://schemas.microsoft.com/office/drawing/2014/main" id="{378D3F9F-6ED3-4BD4-9F95-E075E9DC32AA}"/>
               </a:ext>
             </a:extLst>
           </p:cNvPr>
@@ -9552,7 +9552,7 @@
           <p:cNvPr id="10" name="s4-right-rule-0">
             <a:extLst xmlns:a="http://schemas.openxmlformats.org/drawingml/2006/main">
               <a:ext uri="{FF2B5EF4-FFF2-40B4-BE49-F238E27FC236}">
-                <a16:creationId xmlns:a16="http://schemas.microsoft.com/office/drawing/2014/main" id="{0DC6990F-49A2-4AA2-8FFA-7D0CD60C2BB5}"/>
+                <a16:creationId xmlns:a16="http://schemas.microsoft.com/office/drawing/2014/main" id="{77702803-D400-49E1-8F3B-976B9211DC02}"/>
               </a:ext>
             </a:extLst>
           </p:cNvPr>
@@ -9583,7 +9583,7 @@
           <p:cNvPr id="11" name="s4-left-1">
             <a:extLst xmlns:a="http://schemas.openxmlformats.org/drawingml/2006/main">
               <a:ext uri="{FF2B5EF4-FFF2-40B4-BE49-F238E27FC236}">
-                <a16:creationId xmlns:a16="http://schemas.microsoft.com/office/drawing/2014/main" id="{21A8168E-1C47-4206-B115-1183EB8C47B2}"/>
+                <a16:creationId xmlns:a16="http://schemas.microsoft.com/office/drawing/2014/main" id="{EE18F4E5-3B35-4F40-A53E-69B55D9A23B3}"/>
               </a:ext>
             </a:extLst>
           </p:cNvPr>
@@ -9740,7 +9740,7 @@
           <p:cNvPr id="12" name="s4-right-1">
             <a:extLst xmlns:a="http://schemas.openxmlformats.org/drawingml/2006/main">
               <a:ext uri="{FF2B5EF4-FFF2-40B4-BE49-F238E27FC236}">
-                <a16:creationId xmlns:a16="http://schemas.microsoft.com/office/drawing/2014/main" id="{B05FF01F-D4DF-49F7-ADE3-513A0B8F6D87}"/>
+                <a16:creationId xmlns:a16="http://schemas.microsoft.com/office/drawing/2014/main" id="{1CAA7EC5-C783-46E9-B72A-4D1A8E686621}"/>
               </a:ext>
             </a:extLst>
           </p:cNvPr>
@@ -9897,7 +9897,7 @@
           <p:cNvPr id="13" name="s4-left-rule-1">
             <a:extLst xmlns:a="http://schemas.openxmlformats.org/drawingml/2006/main">
               <a:ext uri="{FF2B5EF4-FFF2-40B4-BE49-F238E27FC236}">
-                <a16:creationId xmlns:a16="http://schemas.microsoft.com/office/drawing/2014/main" id="{834783A6-93AA-4A0D-BB38-2CE7BF8AC6C2}"/>
+                <a16:creationId xmlns:a16="http://schemas.microsoft.com/office/drawing/2014/main" id="{3E5CEB92-27ED-4ABD-AF2E-4E408198D219}"/>
               </a:ext>
             </a:extLst>
           </p:cNvPr>
@@ -9928,7 +9928,7 @@
           <p:cNvPr id="14" name="s4-right-rule-1">
             <a:extLst xmlns:a="http://schemas.openxmlformats.org/drawingml/2006/main">
               <a:ext uri="{FF2B5EF4-FFF2-40B4-BE49-F238E27FC236}">
-                <a16:creationId xmlns:a16="http://schemas.microsoft.com/office/drawing/2014/main" id="{24A0D203-4AB7-431D-970D-3C5F30A81EF1}"/>
+                <a16:creationId xmlns:a16="http://schemas.microsoft.com/office/drawing/2014/main" id="{DC5F61DA-7A74-426C-A2BF-CCF3A97E7ECA}"/>
               </a:ext>
             </a:extLst>
           </p:cNvPr>
@@ -9959,7 +9959,7 @@
           <p:cNvPr id="15" name="s4-left-2">
             <a:extLst xmlns:a="http://schemas.openxmlformats.org/drawingml/2006/main">
               <a:ext uri="{FF2B5EF4-FFF2-40B4-BE49-F238E27FC236}">
-                <a16:creationId xmlns:a16="http://schemas.microsoft.com/office/drawing/2014/main" id="{0E285FE9-F493-4F32-8B06-7FA0BF6F5E95}"/>
+                <a16:creationId xmlns:a16="http://schemas.microsoft.com/office/drawing/2014/main" id="{9E30D7D5-8C2D-43F3-8F92-BFC28FA27C66}"/>
               </a:ext>
             </a:extLst>
           </p:cNvPr>
@@ -10116,7 +10116,7 @@
           <p:cNvPr id="16" name="s4-right-2">
             <a:extLst xmlns:a="http://schemas.openxmlformats.org/drawingml/2006/main">
               <a:ext uri="{FF2B5EF4-FFF2-40B4-BE49-F238E27FC236}">
-                <a16:creationId xmlns:a16="http://schemas.microsoft.com/office/drawing/2014/main" id="{CD4333AB-0C3C-4CB9-A0B0-F8B39FFAEDE1}"/>
+                <a16:creationId xmlns:a16="http://schemas.microsoft.com/office/drawing/2014/main" id="{FD7E03B0-8238-4198-A0B3-0F5C30E4DDCD}"/>
               </a:ext>
             </a:extLst>
           </p:cNvPr>
@@ -10273,7 +10273,7 @@
           <p:cNvPr id="17" name="s4-left-rule-2">
             <a:extLst xmlns:a="http://schemas.openxmlformats.org/drawingml/2006/main">
               <a:ext uri="{FF2B5EF4-FFF2-40B4-BE49-F238E27FC236}">
-                <a16:creationId xmlns:a16="http://schemas.microsoft.com/office/drawing/2014/main" id="{CDFC19C9-2217-4892-82F9-88BBFB8E8290}"/>
+                <a16:creationId xmlns:a16="http://schemas.microsoft.com/office/drawing/2014/main" id="{E2525C77-EB73-4C2D-B30F-A60AB06D2E77}"/>
               </a:ext>
             </a:extLst>
           </p:cNvPr>
@@ -10304,7 +10304,7 @@
           <p:cNvPr id="18" name="s4-right-rule-2">
             <a:extLst xmlns:a="http://schemas.openxmlformats.org/drawingml/2006/main">
               <a:ext uri="{FF2B5EF4-FFF2-40B4-BE49-F238E27FC236}">
-                <a16:creationId xmlns:a16="http://schemas.microsoft.com/office/drawing/2014/main" id="{3620B829-F516-422D-8E9B-47B5C173D1C3}"/>
+                <a16:creationId xmlns:a16="http://schemas.microsoft.com/office/drawing/2014/main" id="{EC6E6BDA-483F-4A77-BACC-779056BF76A5}"/>
               </a:ext>
             </a:extLst>
           </p:cNvPr>
@@ -10335,7 +10335,7 @@
           <p:cNvPr id="19" name="s4-left-3">
             <a:extLst xmlns:a="http://schemas.openxmlformats.org/drawingml/2006/main">
               <a:ext uri="{FF2B5EF4-FFF2-40B4-BE49-F238E27FC236}">
-                <a16:creationId xmlns:a16="http://schemas.microsoft.com/office/drawing/2014/main" id="{2DD28D9D-1E82-4F3E-AE8B-D96406ED9EF4}"/>
+                <a16:creationId xmlns:a16="http://schemas.microsoft.com/office/drawing/2014/main" id="{EF5D557F-329E-4E4D-BAAF-69E4E78D938C}"/>
               </a:ext>
             </a:extLst>
           </p:cNvPr>
@@ -10492,7 +10492,7 @@
           <p:cNvPr id="20" name="s4-right-3">
             <a:extLst xmlns:a="http://schemas.openxmlformats.org/drawingml/2006/main">
               <a:ext uri="{FF2B5EF4-FFF2-40B4-BE49-F238E27FC236}">
-                <a16:creationId xmlns:a16="http://schemas.microsoft.com/office/drawing/2014/main" id="{D07A8F0F-1D48-4F71-AC95-0FBB24D28C05}"/>
+                <a16:creationId xmlns:a16="http://schemas.microsoft.com/office/drawing/2014/main" id="{2CF33629-3E17-4196-A297-F8953CB43A60}"/>
               </a:ext>
             </a:extLst>
           </p:cNvPr>
@@ -10649,7 +10649,7 @@
           <p:cNvPr id="21" name="s4-caveat">
             <a:extLst xmlns:a="http://schemas.openxmlformats.org/drawingml/2006/main">
               <a:ext uri="{FF2B5EF4-FFF2-40B4-BE49-F238E27FC236}">
-                <a16:creationId xmlns:a16="http://schemas.microsoft.com/office/drawing/2014/main" id="{AE5B559B-A958-41C7-A969-4ADE2E22DCD9}"/>
+                <a16:creationId xmlns:a16="http://schemas.microsoft.com/office/drawing/2014/main" id="{E7C51640-140E-44E3-98B7-401CC305F00E}"/>
               </a:ext>
             </a:extLst>
           </p:cNvPr>
@@ -10680,7 +10680,7 @@
           <p:cNvPr id="22" name="s4-caveat-title">
             <a:extLst xmlns:a="http://schemas.openxmlformats.org/drawingml/2006/main">
               <a:ext uri="{FF2B5EF4-FFF2-40B4-BE49-F238E27FC236}">
-                <a16:creationId xmlns:a16="http://schemas.microsoft.com/office/drawing/2014/main" id="{DC1951E1-E80F-4DA8-B38F-8BAED7DFD766}"/>
+                <a16:creationId xmlns:a16="http://schemas.microsoft.com/office/drawing/2014/main" id="{16043531-308F-4C88-B2FE-474DC83B6F1C}"/>
               </a:ext>
             </a:extLst>
           </p:cNvPr>
@@ -10837,7 +10837,7 @@
           <p:cNvPr id="23" name="s4-caveat-body">
             <a:extLst xmlns:a="http://schemas.openxmlformats.org/drawingml/2006/main">
               <a:ext uri="{FF2B5EF4-FFF2-40B4-BE49-F238E27FC236}">
-                <a16:creationId xmlns:a16="http://schemas.microsoft.com/office/drawing/2014/main" id="{CCE76636-836B-402F-B373-C6C4ED8BEEA8}"/>
+                <a16:creationId xmlns:a16="http://schemas.microsoft.com/office/drawing/2014/main" id="{5EA574B1-4F20-4BB7-A797-93B32237F91C}"/>
               </a:ext>
             </a:extLst>
           </p:cNvPr>
@@ -10992,7 +10992,7 @@
     </p:spTree>
     <p:extLst>
       <p:ext uri="{BB962C8B-B14F-4D97-AF65-F5344CB8AC3E}">
-        <p14:creationId xmlns:p14="http://schemas.microsoft.com/office/powerpoint/2010/main" val="794356118"/>
+        <p14:creationId xmlns:p14="http://schemas.microsoft.com/office/powerpoint/2010/main" val="496042524"/>
       </p:ext>
     </p:extLst>
   </p:cSld>
@@ -11023,7 +11023,7 @@
           <p:cNvPr id="13" name="s5-kicker">
             <a:extLst xmlns:a="http://schemas.openxmlformats.org/drawingml/2006/main">
               <a:ext uri="{FF2B5EF4-FFF2-40B4-BE49-F238E27FC236}">
-                <a16:creationId xmlns:a16="http://schemas.microsoft.com/office/drawing/2014/main" id="{A71CA3E6-F2AF-4BA8-B435-C7987A541FE3}"/>
+                <a16:creationId xmlns:a16="http://schemas.microsoft.com/office/drawing/2014/main" id="{F6B428A6-C540-4C09-9782-107FB34FC966}"/>
               </a:ext>
             </a:extLst>
           </p:cNvPr>
@@ -11180,7 +11180,7 @@
           <p:cNvPr id="2" name="s5-title">
             <a:extLst xmlns:a="http://schemas.openxmlformats.org/drawingml/2006/main">
               <a:ext uri="{FF2B5EF4-FFF2-40B4-BE49-F238E27FC236}">
-                <a16:creationId xmlns:a16="http://schemas.microsoft.com/office/drawing/2014/main" id="{0866EEA4-D4F6-4644-84EC-3BAFDD6958AA}"/>
+                <a16:creationId xmlns:a16="http://schemas.microsoft.com/office/drawing/2014/main" id="{610012FA-96A4-421C-9103-584A487E1383}"/>
               </a:ext>
             </a:extLst>
           </p:cNvPr>
@@ -11337,7 +11337,7 @@
           <p:cNvPr id="3" name="s5-market-label">
             <a:extLst xmlns:a="http://schemas.openxmlformats.org/drawingml/2006/main">
               <a:ext uri="{FF2B5EF4-FFF2-40B4-BE49-F238E27FC236}">
-                <a16:creationId xmlns:a16="http://schemas.microsoft.com/office/drawing/2014/main" id="{C34935C6-2E33-40FF-A499-129A6456B016}"/>
+                <a16:creationId xmlns:a16="http://schemas.microsoft.com/office/drawing/2014/main" id="{73B8AE91-32F2-4910-B818-32CBDF34B4D4}"/>
               </a:ext>
             </a:extLst>
           </p:cNvPr>
@@ -11494,7 +11494,7 @@
           <p:cNvPr id="4" name="s5-market">
             <a:extLst xmlns:a="http://schemas.openxmlformats.org/drawingml/2006/main">
               <a:ext uri="{FF2B5EF4-FFF2-40B4-BE49-F238E27FC236}">
-                <a16:creationId xmlns:a16="http://schemas.microsoft.com/office/drawing/2014/main" id="{1A81BD59-B9AD-412B-9B91-44C6CA486E1B}"/>
+                <a16:creationId xmlns:a16="http://schemas.microsoft.com/office/drawing/2014/main" id="{B8825DA0-FF61-45D9-A7E2-C135AC2F92EA}"/>
               </a:ext>
             </a:extLst>
           </p:cNvPr>
@@ -11651,7 +11651,7 @@
           <p:cNvPr id="5" name="s5-divider">
             <a:extLst xmlns:a="http://schemas.openxmlformats.org/drawingml/2006/main">
               <a:ext uri="{FF2B5EF4-FFF2-40B4-BE49-F238E27FC236}">
-                <a16:creationId xmlns:a16="http://schemas.microsoft.com/office/drawing/2014/main" id="{EB8C318F-1798-4964-95FB-E334636BAC5C}"/>
+                <a16:creationId xmlns:a16="http://schemas.microsoft.com/office/drawing/2014/main" id="{FA25CC64-F80C-4AB8-9106-F1FE34345E4F}"/>
               </a:ext>
             </a:extLst>
           </p:cNvPr>
@@ -11682,7 +11682,7 @@
           <p:cNvPr id="6" name="s5-wedge-label">
             <a:extLst xmlns:a="http://schemas.openxmlformats.org/drawingml/2006/main">
               <a:ext uri="{FF2B5EF4-FFF2-40B4-BE49-F238E27FC236}">
-                <a16:creationId xmlns:a16="http://schemas.microsoft.com/office/drawing/2014/main" id="{B43AA22E-B336-4A29-8EE0-8E811CA52EAD}"/>
+                <a16:creationId xmlns:a16="http://schemas.microsoft.com/office/drawing/2014/main" id="{BBC36F9C-6B06-41D8-84C7-5000041E04C7}"/>
               </a:ext>
             </a:extLst>
           </p:cNvPr>
@@ -11839,7 +11839,7 @@
           <p:cNvPr id="7" name="s5-wedge">
             <a:extLst xmlns:a="http://schemas.openxmlformats.org/drawingml/2006/main">
               <a:ext uri="{FF2B5EF4-FFF2-40B4-BE49-F238E27FC236}">
-                <a16:creationId xmlns:a16="http://schemas.microsoft.com/office/drawing/2014/main" id="{954EC5D0-8745-42AC-B0B4-217DA3CD3972}"/>
+                <a16:creationId xmlns:a16="http://schemas.microsoft.com/office/drawing/2014/main" id="{B60E2487-0803-4798-992D-E36376AF4F4D}"/>
               </a:ext>
             </a:extLst>
           </p:cNvPr>
@@ -11996,7 +11996,7 @@
           <p:cNvPr id="8" name="s5-roadmap-label">
             <a:extLst xmlns:a="http://schemas.openxmlformats.org/drawingml/2006/main">
               <a:ext uri="{FF2B5EF4-FFF2-40B4-BE49-F238E27FC236}">
-                <a16:creationId xmlns:a16="http://schemas.microsoft.com/office/drawing/2014/main" id="{AA7ADDBB-2FCD-4434-9664-07F43003FF5E}"/>
+                <a16:creationId xmlns:a16="http://schemas.microsoft.com/office/drawing/2014/main" id="{20EB3C21-76A5-499A-8300-66D43EE25250}"/>
               </a:ext>
             </a:extLst>
           </p:cNvPr>
@@ -12153,7 +12153,7 @@
           <p:cNvPr id="9" name="s5-roadmap">
             <a:extLst xmlns:a="http://schemas.openxmlformats.org/drawingml/2006/main">
               <a:ext uri="{FF2B5EF4-FFF2-40B4-BE49-F238E27FC236}">
-                <a16:creationId xmlns:a16="http://schemas.microsoft.com/office/drawing/2014/main" id="{CDB43175-2A55-445A-B984-764713963CBD}"/>
+                <a16:creationId xmlns:a16="http://schemas.microsoft.com/office/drawing/2014/main" id="{39BA3F5B-C637-4E8A-99D1-B3BB763D3100}"/>
               </a:ext>
             </a:extLst>
           </p:cNvPr>
@@ -12310,7 +12310,7 @@
           <p:cNvPr id="10" name="s5-footer-rule">
             <a:extLst xmlns:a="http://schemas.openxmlformats.org/drawingml/2006/main">
               <a:ext uri="{FF2B5EF4-FFF2-40B4-BE49-F238E27FC236}">
-                <a16:creationId xmlns:a16="http://schemas.microsoft.com/office/drawing/2014/main" id="{7A990BD9-ED8F-4474-87A3-D9403332D3BC}"/>
+                <a16:creationId xmlns:a16="http://schemas.microsoft.com/office/drawing/2014/main" id="{DF3D78E8-1F0D-4438-B232-2A55EDAE8BC1}"/>
               </a:ext>
             </a:extLst>
           </p:cNvPr>
@@ -12341,7 +12341,7 @@
           <p:cNvPr id="11" name="s5-status">
             <a:extLst xmlns:a="http://schemas.openxmlformats.org/drawingml/2006/main">
               <a:ext uri="{FF2B5EF4-FFF2-40B4-BE49-F238E27FC236}">
-                <a16:creationId xmlns:a16="http://schemas.microsoft.com/office/drawing/2014/main" id="{39CA4219-9105-43BA-9604-666C58648A23}"/>
+                <a16:creationId xmlns:a16="http://schemas.microsoft.com/office/drawing/2014/main" id="{17E2A9AF-A574-40BF-AF55-AB07E4328495}"/>
               </a:ext>
             </a:extLst>
           </p:cNvPr>
@@ -12498,7 +12498,7 @@
           <p:cNvPr id="12" name="s5-page">
             <a:extLst xmlns:a="http://schemas.openxmlformats.org/drawingml/2006/main">
               <a:ext uri="{FF2B5EF4-FFF2-40B4-BE49-F238E27FC236}">
-                <a16:creationId xmlns:a16="http://schemas.microsoft.com/office/drawing/2014/main" id="{968DDA7E-9AF6-470C-ADCA-C0CC6199C733}"/>
+                <a16:creationId xmlns:a16="http://schemas.microsoft.com/office/drawing/2014/main" id="{3963CE31-4164-4440-8DE9-3F17B4A5F230}"/>
               </a:ext>
             </a:extLst>
           </p:cNvPr>
@@ -12653,7 +12653,7 @@
     </p:spTree>
     <p:extLst>
       <p:ext uri="{BB962C8B-B14F-4D97-AF65-F5344CB8AC3E}">
-        <p14:creationId xmlns:p14="http://schemas.microsoft.com/office/powerpoint/2010/main" val="1762398013"/>
+        <p14:creationId xmlns:p14="http://schemas.microsoft.com/office/powerpoint/2010/main" val="2134824148"/>
       </p:ext>
     </p:extLst>
   </p:cSld>

</xml_diff>